<commit_message>
Added slide for python installation
</commit_message>
<xml_diff>
--- a/Introduction to Python and Data Analysis.pptx
+++ b/Introduction to Python and Data Analysis.pptx
@@ -7,33 +7,34 @@
   <p:sldIdLst>
     <p:sldId id="256" r:id="rId5"/>
     <p:sldId id="257" r:id="rId6"/>
-    <p:sldId id="258" r:id="rId7"/>
-    <p:sldId id="259" r:id="rId8"/>
-    <p:sldId id="260" r:id="rId9"/>
-    <p:sldId id="261" r:id="rId10"/>
-    <p:sldId id="262" r:id="rId11"/>
-    <p:sldId id="263" r:id="rId12"/>
-    <p:sldId id="264" r:id="rId13"/>
-    <p:sldId id="265" r:id="rId14"/>
-    <p:sldId id="266" r:id="rId15"/>
-    <p:sldId id="267" r:id="rId16"/>
-    <p:sldId id="268" r:id="rId17"/>
-    <p:sldId id="270" r:id="rId18"/>
-    <p:sldId id="269" r:id="rId19"/>
-    <p:sldId id="271" r:id="rId20"/>
-    <p:sldId id="272" r:id="rId21"/>
-    <p:sldId id="273" r:id="rId22"/>
-    <p:sldId id="274" r:id="rId23"/>
-    <p:sldId id="275" r:id="rId24"/>
-    <p:sldId id="276" r:id="rId25"/>
-    <p:sldId id="277" r:id="rId26"/>
-    <p:sldId id="278" r:id="rId27"/>
-    <p:sldId id="279" r:id="rId28"/>
-    <p:sldId id="280" r:id="rId29"/>
-    <p:sldId id="281" r:id="rId30"/>
-    <p:sldId id="282" r:id="rId31"/>
-    <p:sldId id="283" r:id="rId32"/>
-    <p:sldId id="284" r:id="rId33"/>
+    <p:sldId id="285" r:id="rId7"/>
+    <p:sldId id="258" r:id="rId8"/>
+    <p:sldId id="259" r:id="rId9"/>
+    <p:sldId id="260" r:id="rId10"/>
+    <p:sldId id="261" r:id="rId11"/>
+    <p:sldId id="262" r:id="rId12"/>
+    <p:sldId id="263" r:id="rId13"/>
+    <p:sldId id="264" r:id="rId14"/>
+    <p:sldId id="265" r:id="rId15"/>
+    <p:sldId id="266" r:id="rId16"/>
+    <p:sldId id="267" r:id="rId17"/>
+    <p:sldId id="268" r:id="rId18"/>
+    <p:sldId id="270" r:id="rId19"/>
+    <p:sldId id="269" r:id="rId20"/>
+    <p:sldId id="271" r:id="rId21"/>
+    <p:sldId id="272" r:id="rId22"/>
+    <p:sldId id="273" r:id="rId23"/>
+    <p:sldId id="274" r:id="rId24"/>
+    <p:sldId id="275" r:id="rId25"/>
+    <p:sldId id="276" r:id="rId26"/>
+    <p:sldId id="277" r:id="rId27"/>
+    <p:sldId id="278" r:id="rId28"/>
+    <p:sldId id="279" r:id="rId29"/>
+    <p:sldId id="280" r:id="rId30"/>
+    <p:sldId id="281" r:id="rId31"/>
+    <p:sldId id="282" r:id="rId32"/>
+    <p:sldId id="283" r:id="rId33"/>
+    <p:sldId id="284" r:id="rId34"/>
   </p:sldIdLst>
   <p:sldSz cx="12192000" cy="6858000"/>
   <p:notesSz cx="6858000" cy="9144000"/>
@@ -143,7 +144,7 @@
 <file path=ppt/revisionInfo.xml><?xml version="1.0" encoding="utf-8"?>
 <p1510:revInfo xmlns:a="http://schemas.openxmlformats.org/drawingml/2006/main" xmlns:r="http://schemas.openxmlformats.org/officeDocument/2006/relationships" xmlns:p1510="http://schemas.microsoft.com/office/powerpoint/2015/10/main">
   <p1510:revLst>
-    <p1510:client id="{A81BAEAF-2EB1-4FF4-8A36-0874334D53E8}" v="82" dt="2026-03-23T10:36:16.529"/>
+    <p1510:client id="{DFBF8857-7E0D-493D-B7D1-1294FDCF2F14}" v="8" dt="2026-04-03T15:15:29.311"/>
   </p1510:revLst>
 </p1510:revInfo>
 </file>
@@ -153,7 +154,7 @@
   <pc:docChgLst>
     <pc:chgData name="Andrea Misiti" userId="662b9334-fbcf-4af2-8e89-b299705417ff" providerId="ADAL" clId="{249864A4-316A-45F1-91C7-6860A5D0EB98}"/>
     <pc:docChg chg="undo redo custSel addSld delSld modSld">
-      <pc:chgData name="Andrea Misiti" userId="662b9334-fbcf-4af2-8e89-b299705417ff" providerId="ADAL" clId="{249864A4-316A-45F1-91C7-6860A5D0EB98}" dt="2026-03-23T14:41:28.514" v="10120" actId="20577"/>
+      <pc:chgData name="Andrea Misiti" userId="662b9334-fbcf-4af2-8e89-b299705417ff" providerId="ADAL" clId="{249864A4-316A-45F1-91C7-6860A5D0EB98}" dt="2026-03-26T13:27:04.385" v="10123"/>
       <pc:docMkLst>
         <pc:docMk/>
       </pc:docMkLst>
@@ -218,8 +219,8 @@
           </ac:spMkLst>
         </pc:spChg>
       </pc:sldChg>
-      <pc:sldChg chg="addSp modSp new mod">
-        <pc:chgData name="Andrea Misiti" userId="662b9334-fbcf-4af2-8e89-b299705417ff" providerId="ADAL" clId="{249864A4-316A-45F1-91C7-6860A5D0EB98}" dt="2026-03-20T14:32:09.247" v="3503" actId="113"/>
+      <pc:sldChg chg="addSp delSp modSp new mod">
+        <pc:chgData name="Andrea Misiti" userId="662b9334-fbcf-4af2-8e89-b299705417ff" providerId="ADAL" clId="{249864A4-316A-45F1-91C7-6860A5D0EB98}" dt="2026-03-26T13:27:04.385" v="10123"/>
         <pc:sldMkLst>
           <pc:docMk/>
           <pc:sldMk cId="505946796" sldId="268"/>
@@ -238,14 +239,6 @@
             <pc:docMk/>
             <pc:sldMk cId="505946796" sldId="268"/>
             <ac:spMk id="3" creationId="{343000CC-9146-B2C7-E3DD-BF2BDACC8804}"/>
-          </ac:spMkLst>
-        </pc:spChg>
-        <pc:spChg chg="add">
-          <ac:chgData name="Andrea Misiti" userId="662b9334-fbcf-4af2-8e89-b299705417ff" providerId="ADAL" clId="{249864A4-316A-45F1-91C7-6860A5D0EB98}" dt="2026-03-20T10:11:57.398" v="1870"/>
-          <ac:spMkLst>
-            <pc:docMk/>
-            <pc:sldMk cId="505946796" sldId="268"/>
-            <ac:spMk id="4" creationId="{A5FD8ADF-3836-CD65-A1B7-4B6C6995991F}"/>
           </ac:spMkLst>
         </pc:spChg>
       </pc:sldChg>
@@ -503,38 +496,6 @@
             <ac:spMk id="3" creationId="{F63EE49B-477C-411F-BC05-B79BA277FDF9}"/>
           </ac:spMkLst>
         </pc:spChg>
-        <pc:spChg chg="add del">
-          <ac:chgData name="Andrea Misiti" userId="662b9334-fbcf-4af2-8e89-b299705417ff" providerId="ADAL" clId="{249864A4-316A-45F1-91C7-6860A5D0EB98}" dt="2026-03-23T10:09:45.877" v="5924" actId="26606"/>
-          <ac:spMkLst>
-            <pc:docMk/>
-            <pc:sldMk cId="1066570899" sldId="277"/>
-            <ac:spMk id="9" creationId="{600DC1B0-7E1A-BD02-3F93-19E6B1B75075}"/>
-          </ac:spMkLst>
-        </pc:spChg>
-        <pc:spChg chg="add del">
-          <ac:chgData name="Andrea Misiti" userId="662b9334-fbcf-4af2-8e89-b299705417ff" providerId="ADAL" clId="{249864A4-316A-45F1-91C7-6860A5D0EB98}" dt="2026-03-23T10:09:50.794" v="5926" actId="26606"/>
-          <ac:spMkLst>
-            <pc:docMk/>
-            <pc:sldMk cId="1066570899" sldId="277"/>
-            <ac:spMk id="11" creationId="{600DC1B0-7E1A-BD02-3F93-19E6B1B75075}"/>
-          </ac:spMkLst>
-        </pc:spChg>
-        <pc:graphicFrameChg chg="add del">
-          <ac:chgData name="Andrea Misiti" userId="662b9334-fbcf-4af2-8e89-b299705417ff" providerId="ADAL" clId="{249864A4-316A-45F1-91C7-6860A5D0EB98}" dt="2026-03-23T10:09:45.877" v="5924" actId="26606"/>
-          <ac:graphicFrameMkLst>
-            <pc:docMk/>
-            <pc:sldMk cId="1066570899" sldId="277"/>
-            <ac:graphicFrameMk id="5" creationId="{F02D687E-387F-BAE7-47BD-EF93083826BE}"/>
-          </ac:graphicFrameMkLst>
-        </pc:graphicFrameChg>
-        <pc:graphicFrameChg chg="add del">
-          <ac:chgData name="Andrea Misiti" userId="662b9334-fbcf-4af2-8e89-b299705417ff" providerId="ADAL" clId="{249864A4-316A-45F1-91C7-6860A5D0EB98}" dt="2026-03-23T10:09:50.794" v="5926" actId="26606"/>
-          <ac:graphicFrameMkLst>
-            <pc:docMk/>
-            <pc:sldMk cId="1066570899" sldId="277"/>
-            <ac:graphicFrameMk id="12" creationId="{2487CA10-3E87-4B6C-7CA6-84571792C0F8}"/>
-          </ac:graphicFrameMkLst>
-        </pc:graphicFrameChg>
       </pc:sldChg>
       <pc:sldChg chg="modSp new add del mod">
         <pc:chgData name="Andrea Misiti" userId="662b9334-fbcf-4af2-8e89-b299705417ff" providerId="ADAL" clId="{249864A4-316A-45F1-91C7-6860A5D0EB98}" dt="2026-03-23T10:27:44.625" v="7243"/>
@@ -696,6 +657,62 @@
             <ac:spMk id="3" creationId="{7CD91063-F5F7-BF5E-4880-26467A9AF6F6}"/>
           </ac:spMkLst>
         </pc:spChg>
+      </pc:sldChg>
+    </pc:docChg>
+  </pc:docChgLst>
+  <pc:docChgLst>
+    <pc:chgData name="Andrea Misiti" userId="662b9334-fbcf-4af2-8e89-b299705417ff" providerId="ADAL" clId="{8B0E5DBC-70F7-47A2-A44B-D06CC56641D4}"/>
+    <pc:docChg chg="custSel addSld modSld">
+      <pc:chgData name="Andrea Misiti" userId="662b9334-fbcf-4af2-8e89-b299705417ff" providerId="ADAL" clId="{8B0E5DBC-70F7-47A2-A44B-D06CC56641D4}" dt="2026-04-03T15:19:53.576" v="404" actId="26606"/>
+      <pc:docMkLst>
+        <pc:docMk/>
+      </pc:docMkLst>
+      <pc:sldChg chg="addSp delSp modSp new mod setBg">
+        <pc:chgData name="Andrea Misiti" userId="662b9334-fbcf-4af2-8e89-b299705417ff" providerId="ADAL" clId="{8B0E5DBC-70F7-47A2-A44B-D06CC56641D4}" dt="2026-04-03T15:19:53.576" v="404" actId="26606"/>
+        <pc:sldMkLst>
+          <pc:docMk/>
+          <pc:sldMk cId="3164938394" sldId="285"/>
+        </pc:sldMkLst>
+        <pc:spChg chg="mod">
+          <ac:chgData name="Andrea Misiti" userId="662b9334-fbcf-4af2-8e89-b299705417ff" providerId="ADAL" clId="{8B0E5DBC-70F7-47A2-A44B-D06CC56641D4}" dt="2026-04-03T15:16:00.884" v="260" actId="26606"/>
+          <ac:spMkLst>
+            <pc:docMk/>
+            <pc:sldMk cId="3164938394" sldId="285"/>
+            <ac:spMk id="2" creationId="{494D33B3-0B15-8BEC-6A5C-059A0374852F}"/>
+          </ac:spMkLst>
+        </pc:spChg>
+        <pc:spChg chg="mod">
+          <ac:chgData name="Andrea Misiti" userId="662b9334-fbcf-4af2-8e89-b299705417ff" providerId="ADAL" clId="{8B0E5DBC-70F7-47A2-A44B-D06CC56641D4}" dt="2026-04-03T15:19:53.576" v="404" actId="26606"/>
+          <ac:spMkLst>
+            <pc:docMk/>
+            <pc:sldMk cId="3164938394" sldId="285"/>
+            <ac:spMk id="3" creationId="{C73270CD-DEC2-7958-52DE-81F544B70367}"/>
+          </ac:spMkLst>
+        </pc:spChg>
+        <pc:spChg chg="add del">
+          <ac:chgData name="Andrea Misiti" userId="662b9334-fbcf-4af2-8e89-b299705417ff" providerId="ADAL" clId="{8B0E5DBC-70F7-47A2-A44B-D06CC56641D4}" dt="2026-04-03T15:19:53.576" v="404" actId="26606"/>
+          <ac:spMkLst>
+            <pc:docMk/>
+            <pc:sldMk cId="3164938394" sldId="285"/>
+            <ac:spMk id="1031" creationId="{CBB0869A-0BE5-B3E9-F73D-2F3691E4D932}"/>
+          </ac:spMkLst>
+        </pc:spChg>
+        <pc:spChg chg="add">
+          <ac:chgData name="Andrea Misiti" userId="662b9334-fbcf-4af2-8e89-b299705417ff" providerId="ADAL" clId="{8B0E5DBC-70F7-47A2-A44B-D06CC56641D4}" dt="2026-04-03T15:19:53.576" v="404" actId="26606"/>
+          <ac:spMkLst>
+            <pc:docMk/>
+            <pc:sldMk cId="3164938394" sldId="285"/>
+            <ac:spMk id="1036" creationId="{CBB0869A-0BE5-B3E9-F73D-2F3691E4D932}"/>
+          </ac:spMkLst>
+        </pc:spChg>
+        <pc:picChg chg="add mod">
+          <ac:chgData name="Andrea Misiti" userId="662b9334-fbcf-4af2-8e89-b299705417ff" providerId="ADAL" clId="{8B0E5DBC-70F7-47A2-A44B-D06CC56641D4}" dt="2026-04-03T15:16:00.884" v="260" actId="26606"/>
+          <ac:picMkLst>
+            <pc:docMk/>
+            <pc:sldMk cId="3164938394" sldId="285"/>
+            <ac:picMk id="1026" creationId="{2670CDB7-9E6C-3EC8-9AF5-6EF7C24252F5}"/>
+          </ac:picMkLst>
+        </pc:picChg>
       </pc:sldChg>
     </pc:docChg>
   </pc:docChgLst>
@@ -5826,7 +5843,7 @@
           <a:p>
             <a:fld id="{C128FA71-3A18-48C0-980F-4B68F7F63042}" type="datetime1">
               <a:rPr lang="en-US" smtClean="0"/>
-              <a:t>3/23/2026</a:t>
+              <a:t>4/3/2026</a:t>
             </a:fld>
             <a:endParaRPr lang="en-US"/>
           </a:p>
@@ -5880,7 +5897,7 @@
           <a:p>
             <a:fld id="{CC057153-B650-4DEB-B370-79DDCFDCE934}" type="slidenum">
               <a:rPr lang="en-US" smtClean="0"/>
-              <a:t>‹#›</a:t>
+              <a:t>‹N›</a:t>
             </a:fld>
             <a:endParaRPr lang="en-US"/>
           </a:p>
@@ -6034,7 +6051,7 @@
           <a:p>
             <a:fld id="{7104EDB3-C0E8-45F8-9E1D-1B6C8D1880C0}" type="datetime1">
               <a:rPr lang="en-US" smtClean="0"/>
-              <a:t>3/23/2026</a:t>
+              <a:t>4/3/2026</a:t>
             </a:fld>
             <a:endParaRPr lang="en-US"/>
           </a:p>
@@ -6088,7 +6105,7 @@
           <a:p>
             <a:fld id="{CC057153-B650-4DEB-B370-79DDCFDCE934}" type="slidenum">
               <a:rPr lang="en-US" smtClean="0"/>
-              <a:t>‹#›</a:t>
+              <a:t>‹N›</a:t>
             </a:fld>
             <a:endParaRPr lang="en-US"/>
           </a:p>
@@ -6244,7 +6261,7 @@
           <a:p>
             <a:fld id="{9CF0EC4B-54ED-4041-B552-9BA760FA3DBA}" type="datetime1">
               <a:rPr lang="en-US" smtClean="0"/>
-              <a:t>3/23/2026</a:t>
+              <a:t>4/3/2026</a:t>
             </a:fld>
             <a:endParaRPr lang="en-US"/>
           </a:p>
@@ -6298,7 +6315,7 @@
           <a:p>
             <a:fld id="{CC057153-B650-4DEB-B370-79DDCFDCE934}" type="slidenum">
               <a:rPr lang="en-US" smtClean="0"/>
-              <a:t>‹#›</a:t>
+              <a:t>‹N›</a:t>
             </a:fld>
             <a:endParaRPr lang="en-US"/>
           </a:p>
@@ -6442,7 +6459,7 @@
           <a:p>
             <a:fld id="{51C1210E-201E-4473-82AC-2466F5386C38}" type="datetime1">
               <a:rPr lang="en-US" smtClean="0"/>
-              <a:t>3/23/2026</a:t>
+              <a:t>4/3/2026</a:t>
             </a:fld>
             <a:endParaRPr lang="en-US"/>
           </a:p>
@@ -6496,7 +6513,7 @@
           <a:p>
             <a:fld id="{CC057153-B650-4DEB-B370-79DDCFDCE934}" type="slidenum">
               <a:rPr lang="en-US" smtClean="0"/>
-              <a:t>‹#›</a:t>
+              <a:t>‹N›</a:t>
             </a:fld>
             <a:endParaRPr lang="en-US"/>
           </a:p>
@@ -6720,7 +6737,7 @@
           <a:p>
             <a:fld id="{B01EA198-6CAB-4B8F-B93F-1F9C8C4B6CE7}" type="datetime1">
               <a:rPr lang="en-US" smtClean="0"/>
-              <a:t>3/23/2026</a:t>
+              <a:t>4/3/2026</a:t>
             </a:fld>
             <a:endParaRPr lang="en-US"/>
           </a:p>
@@ -6774,7 +6791,7 @@
           <a:p>
             <a:fld id="{CC057153-B650-4DEB-B370-79DDCFDCE934}" type="slidenum">
               <a:rPr lang="en-US" smtClean="0"/>
-              <a:t>‹#›</a:t>
+              <a:t>‹N›</a:t>
             </a:fld>
             <a:endParaRPr lang="en-US"/>
           </a:p>
@@ -6992,7 +7009,7 @@
           <a:p>
             <a:fld id="{CA06041F-4525-44D5-AA4F-332294BF1F56}" type="datetime1">
               <a:rPr lang="en-US" smtClean="0"/>
-              <a:t>3/23/2026</a:t>
+              <a:t>4/3/2026</a:t>
             </a:fld>
             <a:endParaRPr lang="en-US"/>
           </a:p>
@@ -7046,7 +7063,7 @@
           <a:p>
             <a:fld id="{CC057153-B650-4DEB-B370-79DDCFDCE934}" type="slidenum">
               <a:rPr lang="en-US" smtClean="0"/>
-              <a:t>‹#›</a:t>
+              <a:t>‹N›</a:t>
             </a:fld>
             <a:endParaRPr lang="en-US"/>
           </a:p>
@@ -7416,7 +7433,7 @@
           <a:p>
             <a:fld id="{F9557091-BBDF-4EB9-BA6B-2BB67AC4FC0F}" type="datetime1">
               <a:rPr lang="en-US" smtClean="0"/>
-              <a:t>3/23/2026</a:t>
+              <a:t>4/3/2026</a:t>
             </a:fld>
             <a:endParaRPr lang="en-US"/>
           </a:p>
@@ -7470,7 +7487,7 @@
           <a:p>
             <a:fld id="{CC057153-B650-4DEB-B370-79DDCFDCE934}" type="slidenum">
               <a:rPr lang="en-US" smtClean="0"/>
-              <a:t>‹#›</a:t>
+              <a:t>‹N›</a:t>
             </a:fld>
             <a:endParaRPr lang="en-US"/>
           </a:p>
@@ -7557,7 +7574,7 @@
           <a:p>
             <a:fld id="{2D6B226B-77A6-410C-9796-083F278E0125}" type="datetime1">
               <a:rPr lang="en-US" smtClean="0"/>
-              <a:t>3/23/2026</a:t>
+              <a:t>4/3/2026</a:t>
             </a:fld>
             <a:endParaRPr lang="en-US"/>
           </a:p>
@@ -7611,7 +7628,7 @@
           <a:p>
             <a:fld id="{CC057153-B650-4DEB-B370-79DDCFDCE934}" type="slidenum">
               <a:rPr lang="en-US" smtClean="0"/>
-              <a:t>‹#›</a:t>
+              <a:t>‹N›</a:t>
             </a:fld>
             <a:endParaRPr lang="en-US"/>
           </a:p>
@@ -7670,7 +7687,7 @@
           <a:p>
             <a:fld id="{A23A578B-D289-4C40-8593-3D356C49DA58}" type="datetime1">
               <a:rPr lang="en-US" smtClean="0"/>
-              <a:t>3/23/2026</a:t>
+              <a:t>4/3/2026</a:t>
             </a:fld>
             <a:endParaRPr lang="en-US"/>
           </a:p>
@@ -7724,7 +7741,7 @@
           <a:p>
             <a:fld id="{CC057153-B650-4DEB-B370-79DDCFDCE934}" type="slidenum">
               <a:rPr lang="en-US" smtClean="0"/>
-              <a:t>‹#›</a:t>
+              <a:t>‹N›</a:t>
             </a:fld>
             <a:endParaRPr lang="en-US"/>
           </a:p>
@@ -7989,7 +8006,7 @@
           <a:p>
             <a:fld id="{713DFAE3-14DB-48A7-A80F-80DDB072CE3D}" type="datetime1">
               <a:rPr lang="en-US" smtClean="0"/>
-              <a:t>3/23/2026</a:t>
+              <a:t>4/3/2026</a:t>
             </a:fld>
             <a:endParaRPr lang="en-US"/>
           </a:p>
@@ -8043,7 +8060,7 @@
           <a:p>
             <a:fld id="{CC057153-B650-4DEB-B370-79DDCFDCE934}" type="slidenum">
               <a:rPr lang="en-US" smtClean="0"/>
-              <a:t>‹#›</a:t>
+              <a:t>‹N›</a:t>
             </a:fld>
             <a:endParaRPr lang="en-US"/>
           </a:p>
@@ -8283,7 +8300,7 @@
           <a:p>
             <a:fld id="{92C5EAEF-6478-4102-8F5D-A5FE9FC97ACB}" type="datetime1">
               <a:rPr lang="en-US" smtClean="0"/>
-              <a:t>3/23/2026</a:t>
+              <a:t>4/3/2026</a:t>
             </a:fld>
             <a:endParaRPr lang="en-US"/>
           </a:p>
@@ -8337,7 +8354,7 @@
           <a:p>
             <a:fld id="{CC057153-B650-4DEB-B370-79DDCFDCE934}" type="slidenum">
               <a:rPr lang="en-US" smtClean="0"/>
-              <a:t>‹#›</a:t>
+              <a:t>‹N›</a:t>
             </a:fld>
             <a:endParaRPr lang="en-US"/>
           </a:p>
@@ -8524,7 +8541,7 @@
           <a:p>
             <a:fld id="{67F45AC6-C491-4585-A584-9CE2AF7D5500}" type="datetime1">
               <a:rPr lang="en-US" smtClean="0"/>
-              <a:t>3/23/2026</a:t>
+              <a:t>4/3/2026</a:t>
             </a:fld>
             <a:endParaRPr lang="en-US"/>
           </a:p>
@@ -8610,7 +8627,7 @@
           <a:p>
             <a:fld id="{CC057153-B650-4DEB-B370-79DDCFDCE934}" type="slidenum">
               <a:rPr lang="en-US" smtClean="0"/>
-              <a:t>‹#›</a:t>
+              <a:t>‹N›</a:t>
             </a:fld>
             <a:endParaRPr lang="en-US"/>
           </a:p>
@@ -9228,6 +9245,155 @@
           <p:cNvPr id="2" name="Title 1">
             <a:extLst>
               <a:ext uri="{FF2B5EF4-FFF2-40B4-BE49-F238E27FC236}">
+                <a16:creationId xmlns:a16="http://schemas.microsoft.com/office/drawing/2014/main" id="{6DFACE75-B5B1-A22A-A7D1-B9F6CCFF82DC}"/>
+              </a:ext>
+            </a:extLst>
+          </p:cNvPr>
+          <p:cNvSpPr>
+            <a:spLocks noGrp="1"/>
+          </p:cNvSpPr>
+          <p:nvPr>
+            <p:ph type="title"/>
+          </p:nvPr>
+        </p:nvSpPr>
+        <p:spPr/>
+        <p:txBody>
+          <a:bodyPr/>
+          <a:lstStyle/>
+          <a:p>
+            <a:r>
+              <a:rPr lang="en-US" dirty="0"/>
+              <a:t>Values and types recap</a:t>
+            </a:r>
+            <a:endParaRPr lang="en-BE" dirty="0"/>
+          </a:p>
+        </p:txBody>
+      </p:sp>
+      <p:sp>
+        <p:nvSpPr>
+          <p:cNvPr id="3" name="Content Placeholder 2">
+            <a:extLst>
+              <a:ext uri="{FF2B5EF4-FFF2-40B4-BE49-F238E27FC236}">
+                <a16:creationId xmlns:a16="http://schemas.microsoft.com/office/drawing/2014/main" id="{E341C943-4128-57D6-3A17-5410C64AC24E}"/>
+              </a:ext>
+            </a:extLst>
+          </p:cNvPr>
+          <p:cNvSpPr>
+            <a:spLocks noGrp="1"/>
+          </p:cNvSpPr>
+          <p:nvPr>
+            <p:ph idx="1"/>
+          </p:nvPr>
+        </p:nvSpPr>
+        <p:spPr/>
+        <p:txBody>
+          <a:bodyPr/>
+          <a:lstStyle/>
+          <a:p>
+            <a:r>
+              <a:rPr lang="en-US" b="1" dirty="0"/>
+              <a:t>Integer </a:t>
+            </a:r>
+            <a:r>
+              <a:rPr lang="en-US" dirty="0"/>
+              <a:t>(2)</a:t>
+            </a:r>
+          </a:p>
+          <a:p>
+            <a:endParaRPr lang="en-US" dirty="0"/>
+          </a:p>
+          <a:p>
+            <a:r>
+              <a:rPr lang="en-US" b="1" dirty="0"/>
+              <a:t>Float</a:t>
+            </a:r>
+            <a:r>
+              <a:rPr lang="en-US" dirty="0"/>
+              <a:t> (42.3)</a:t>
+            </a:r>
+          </a:p>
+          <a:p>
+            <a:endParaRPr lang="en-US" b="1" dirty="0"/>
+          </a:p>
+          <a:p>
+            <a:r>
+              <a:rPr lang="en-US" b="1" dirty="0"/>
+              <a:t>String</a:t>
+            </a:r>
+            <a:r>
+              <a:rPr lang="en-US" dirty="0"/>
+              <a:t> (</a:t>
+            </a:r>
+            <a:r>
+              <a:rPr lang="en-BE" dirty="0"/>
+              <a:t>"</a:t>
+            </a:r>
+            <a:r>
+              <a:rPr lang="en-US" dirty="0"/>
+              <a:t>hello</a:t>
+            </a:r>
+            <a:r>
+              <a:rPr lang="en-BE" dirty="0"/>
+              <a:t>"</a:t>
+            </a:r>
+            <a:r>
+              <a:rPr lang="en-US" dirty="0"/>
+              <a:t>)</a:t>
+            </a:r>
+          </a:p>
+          <a:p>
+            <a:endParaRPr lang="en-US" dirty="0"/>
+          </a:p>
+          <a:p>
+            <a:r>
+              <a:rPr lang="en-US" dirty="0"/>
+              <a:t>The type() function tells you what type a value is</a:t>
+            </a:r>
+          </a:p>
+          <a:p>
+            <a:r>
+              <a:rPr lang="en-US" dirty="0"/>
+              <a:t>Int(), float() and str() are functions that convert their argument to the specified type (if possible)</a:t>
+            </a:r>
+            <a:endParaRPr lang="en-BE" dirty="0"/>
+          </a:p>
+        </p:txBody>
+      </p:sp>
+    </p:spTree>
+    <p:extLst>
+      <p:ext uri="{BB962C8B-B14F-4D97-AF65-F5344CB8AC3E}">
+        <p14:creationId xmlns:p14="http://schemas.microsoft.com/office/powerpoint/2010/main" val="2067501582"/>
+      </p:ext>
+    </p:extLst>
+  </p:cSld>
+  <p:clrMapOvr>
+    <a:masterClrMapping/>
+  </p:clrMapOvr>
+</p:sld>
+</file>
+
+<file path=ppt/slides/slide11.xml><?xml version="1.0" encoding="utf-8"?>
+<p:sld xmlns:a="http://schemas.openxmlformats.org/drawingml/2006/main" xmlns:r="http://schemas.openxmlformats.org/officeDocument/2006/relationships" xmlns:p="http://schemas.openxmlformats.org/presentationml/2006/main">
+  <p:cSld>
+    <p:spTree>
+      <p:nvGrpSpPr>
+        <p:cNvPr id="1" name=""/>
+        <p:cNvGrpSpPr/>
+        <p:nvPr/>
+      </p:nvGrpSpPr>
+      <p:grpSpPr>
+        <a:xfrm>
+          <a:off x="0" y="0"/>
+          <a:ext cx="0" cy="0"/>
+          <a:chOff x="0" y="0"/>
+          <a:chExt cx="0" cy="0"/>
+        </a:xfrm>
+      </p:grpSpPr>
+      <p:sp>
+        <p:nvSpPr>
+          <p:cNvPr id="2" name="Title 1">
+            <a:extLst>
+              <a:ext uri="{FF2B5EF4-FFF2-40B4-BE49-F238E27FC236}">
                 <a16:creationId xmlns:a16="http://schemas.microsoft.com/office/drawing/2014/main" id="{ECE72166-C1A3-084A-49CB-904558F769C9}"/>
               </a:ext>
             </a:extLst>
@@ -9335,7 +9501,7 @@
 </p:sld>
 </file>
 
-<file path=ppt/slides/slide11.xml><?xml version="1.0" encoding="utf-8"?>
+<file path=ppt/slides/slide12.xml><?xml version="1.0" encoding="utf-8"?>
 <p:sld xmlns:a="http://schemas.openxmlformats.org/drawingml/2006/main" xmlns:r="http://schemas.openxmlformats.org/officeDocument/2006/relationships" xmlns:p="http://schemas.openxmlformats.org/presentationml/2006/main">
   <p:cSld>
     <p:spTree>
@@ -9484,7 +9650,7 @@
 </p:sld>
 </file>
 
-<file path=ppt/slides/slide12.xml><?xml version="1.0" encoding="utf-8"?>
+<file path=ppt/slides/slide13.xml><?xml version="1.0" encoding="utf-8"?>
 <p:sld xmlns:a="http://schemas.openxmlformats.org/drawingml/2006/main" xmlns:r="http://schemas.openxmlformats.org/officeDocument/2006/relationships" xmlns:p="http://schemas.openxmlformats.org/presentationml/2006/main">
   <p:cSld>
     <p:spTree>
@@ -9597,7 +9763,7 @@
 </p:sld>
 </file>
 
-<file path=ppt/slides/slide13.xml><?xml version="1.0" encoding="utf-8"?>
+<file path=ppt/slides/slide14.xml><?xml version="1.0" encoding="utf-8"?>
 <p:sld xmlns:a="http://schemas.openxmlformats.org/drawingml/2006/main" xmlns:r="http://schemas.openxmlformats.org/officeDocument/2006/relationships" xmlns:p="http://schemas.openxmlformats.org/presentationml/2006/main">
   <p:cSld>
     <p:spTree>
@@ -9779,113 +9945,6 @@
           </a:p>
         </p:txBody>
       </p:sp>
-      <p:sp>
-        <p:nvSpPr>
-          <p:cNvPr id="4" name="Rectangle 1">
-            <a:extLst>
-              <a:ext uri="{FF2B5EF4-FFF2-40B4-BE49-F238E27FC236}">
-                <a16:creationId xmlns:a16="http://schemas.microsoft.com/office/drawing/2014/main" id="{A5FD8ADF-3836-CD65-A1B7-4B6C6995991F}"/>
-              </a:ext>
-            </a:extLst>
-          </p:cNvPr>
-          <p:cNvSpPr>
-            <a:spLocks noChangeArrowheads="1"/>
-          </p:cNvSpPr>
-          <p:nvPr/>
-        </p:nvSpPr>
-        <p:spPr bwMode="auto">
-          <a:xfrm>
-            <a:off x="0" y="0"/>
-            <a:ext cx="12192000" cy="0"/>
-          </a:xfrm>
-          <a:prstGeom prst="rect">
-            <a:avLst/>
-          </a:prstGeom>
-          <a:noFill/>
-          <a:ln>
-            <a:noFill/>
-          </a:ln>
-          <a:effectLst/>
-          <a:extLst>
-            <a:ext uri="{909E8E84-426E-40DD-AFC4-6F175D3DCCD1}">
-              <a14:hiddenFill xmlns:a14="http://schemas.microsoft.com/office/drawing/2010/main">
-                <a:solidFill>
-                  <a:schemeClr val="accent1"/>
-                </a:solidFill>
-              </a14:hiddenFill>
-            </a:ext>
-            <a:ext uri="{91240B29-F687-4F45-9708-019B960494DF}">
-              <a14:hiddenLine xmlns:a14="http://schemas.microsoft.com/office/drawing/2010/main" w="9525">
-                <a:solidFill>
-                  <a:schemeClr val="tx1"/>
-                </a:solidFill>
-                <a:miter lim="800000"/>
-                <a:headEnd/>
-                <a:tailEnd/>
-              </a14:hiddenLine>
-            </a:ext>
-            <a:ext uri="{AF507438-7753-43E0-B8FC-AC1667EBCBE1}">
-              <a14:hiddenEffects xmlns:a14="http://schemas.microsoft.com/office/drawing/2010/main">
-                <a:effectLst>
-                  <a:outerShdw dist="35921" dir="2700000" algn="ctr" rotWithShape="0">
-                    <a:schemeClr val="bg2"/>
-                  </a:outerShdw>
-                </a:effectLst>
-              </a14:hiddenEffects>
-            </a:ext>
-          </a:extLst>
-        </p:spPr>
-        <p:txBody>
-          <a:bodyPr vert="horz" wrap="none" lIns="91440" tIns="45720" rIns="91440" bIns="45720" numCol="1" anchor="ctr" anchorCtr="0" compatLnSpc="1">
-            <a:prstTxWarp prst="textNoShape">
-              <a:avLst/>
-            </a:prstTxWarp>
-            <a:spAutoFit/>
-          </a:bodyPr>
-          <a:lstStyle/>
-          <a:p>
-            <a:pPr marL="0" marR="0" lvl="0" indent="0" algn="l" defTabSz="914400" rtl="0" eaLnBrk="0" fontAlgn="base" latinLnBrk="0" hangingPunct="0">
-              <a:lnSpc>
-                <a:spcPct val="100000"/>
-              </a:lnSpc>
-              <a:spcBef>
-                <a:spcPct val="0"/>
-              </a:spcBef>
-              <a:spcAft>
-                <a:spcPct val="0"/>
-              </a:spcAft>
-              <a:buClrTx/>
-              <a:buSzTx/>
-              <a:buFontTx/>
-              <a:buNone/>
-              <a:tabLst/>
-            </a:pPr>
-            <a:r>
-              <a:rPr kumimoji="0" lang="en-BE" altLang="en-BE" sz="1000" b="0" i="0" u="none" strike="noStrike" cap="none" normalizeH="0" baseline="0">
-                <a:ln>
-                  <a:noFill/>
-                </a:ln>
-                <a:solidFill>
-                  <a:srgbClr val="333333"/>
-                </a:solidFill>
-                <a:effectLst/>
-                <a:latin typeface="Helvetica Neue"/>
-              </a:rPr>
-              <a:t>https://education.github.com/globalcampus/teacher</a:t>
-            </a:r>
-            <a:endParaRPr kumimoji="0" lang="en-BE" altLang="en-BE" sz="1800" b="0" i="0" u="none" strike="noStrike" cap="none" normalizeH="0" baseline="0">
-              <a:ln>
-                <a:noFill/>
-              </a:ln>
-              <a:solidFill>
-                <a:schemeClr val="tx1"/>
-              </a:solidFill>
-              <a:effectLst/>
-              <a:latin typeface="Arial" panose="020B0604020202020204" pitchFamily="34" charset="0"/>
-            </a:endParaRPr>
-          </a:p>
-        </p:txBody>
-      </p:sp>
     </p:spTree>
     <p:extLst>
       <p:ext uri="{BB962C8B-B14F-4D97-AF65-F5344CB8AC3E}">
@@ -9899,7 +9958,7 @@
 </p:sld>
 </file>
 
-<file path=ppt/slides/slide14.xml><?xml version="1.0" encoding="utf-8"?>
+<file path=ppt/slides/slide15.xml><?xml version="1.0" encoding="utf-8"?>
 <p:sld xmlns:a="http://schemas.openxmlformats.org/drawingml/2006/main" xmlns:r="http://schemas.openxmlformats.org/officeDocument/2006/relationships" xmlns:p="http://schemas.openxmlformats.org/presentationml/2006/main">
   <p:cSld>
     <p:bg>
@@ -10083,7 +10142,7 @@
 </p:sld>
 </file>
 
-<file path=ppt/slides/slide15.xml><?xml version="1.0" encoding="utf-8"?>
+<file path=ppt/slides/slide16.xml><?xml version="1.0" encoding="utf-8"?>
 <p:sld xmlns:a="http://schemas.openxmlformats.org/drawingml/2006/main" xmlns:r="http://schemas.openxmlformats.org/officeDocument/2006/relationships" xmlns:p="http://schemas.openxmlformats.org/presentationml/2006/main">
   <p:cSld>
     <p:spTree>
@@ -10267,7 +10326,7 @@
 </p:sld>
 </file>
 
-<file path=ppt/slides/slide16.xml><?xml version="1.0" encoding="utf-8"?>
+<file path=ppt/slides/slide17.xml><?xml version="1.0" encoding="utf-8"?>
 <p:sld xmlns:a="http://schemas.openxmlformats.org/drawingml/2006/main" xmlns:r="http://schemas.openxmlformats.org/officeDocument/2006/relationships" xmlns:p="http://schemas.openxmlformats.org/presentationml/2006/main">
   <p:cSld>
     <p:spTree>
@@ -10431,7 +10490,7 @@
 </p:sld>
 </file>
 
-<file path=ppt/slides/slide17.xml><?xml version="1.0" encoding="utf-8"?>
+<file path=ppt/slides/slide18.xml><?xml version="1.0" encoding="utf-8"?>
 <p:sld xmlns:a="http://schemas.openxmlformats.org/drawingml/2006/main" xmlns:r="http://schemas.openxmlformats.org/officeDocument/2006/relationships" xmlns:p="http://schemas.openxmlformats.org/presentationml/2006/main">
   <p:cSld>
     <p:spTree>
@@ -10722,7 +10781,7 @@
 </p:sld>
 </file>
 
-<file path=ppt/slides/slide18.xml><?xml version="1.0" encoding="utf-8"?>
+<file path=ppt/slides/slide19.xml><?xml version="1.0" encoding="utf-8"?>
 <p:sld xmlns:a="http://schemas.openxmlformats.org/drawingml/2006/main" xmlns:r="http://schemas.openxmlformats.org/officeDocument/2006/relationships" xmlns:p="http://schemas.openxmlformats.org/presentationml/2006/main">
   <p:cSld>
     <p:spTree>
@@ -10874,200 +10933,6 @@
     <p:extLst>
       <p:ext uri="{BB962C8B-B14F-4D97-AF65-F5344CB8AC3E}">
         <p14:creationId xmlns:p14="http://schemas.microsoft.com/office/powerpoint/2010/main" val="1257633203"/>
-      </p:ext>
-    </p:extLst>
-  </p:cSld>
-  <p:clrMapOvr>
-    <a:masterClrMapping/>
-  </p:clrMapOvr>
-</p:sld>
-</file>
-
-<file path=ppt/slides/slide19.xml><?xml version="1.0" encoding="utf-8"?>
-<p:sld xmlns:a="http://schemas.openxmlformats.org/drawingml/2006/main" xmlns:r="http://schemas.openxmlformats.org/officeDocument/2006/relationships" xmlns:p="http://schemas.openxmlformats.org/presentationml/2006/main">
-  <p:cSld>
-    <p:spTree>
-      <p:nvGrpSpPr>
-        <p:cNvPr id="1" name=""/>
-        <p:cNvGrpSpPr/>
-        <p:nvPr/>
-      </p:nvGrpSpPr>
-      <p:grpSpPr>
-        <a:xfrm>
-          <a:off x="0" y="0"/>
-          <a:ext cx="0" cy="0"/>
-          <a:chOff x="0" y="0"/>
-          <a:chExt cx="0" cy="0"/>
-        </a:xfrm>
-      </p:grpSpPr>
-      <p:sp>
-        <p:nvSpPr>
-          <p:cNvPr id="2" name="Title 1">
-            <a:extLst>
-              <a:ext uri="{FF2B5EF4-FFF2-40B4-BE49-F238E27FC236}">
-                <a16:creationId xmlns:a16="http://schemas.microsoft.com/office/drawing/2014/main" id="{C8C8D859-036E-2FBD-1F83-9D55BD4AD61D}"/>
-              </a:ext>
-            </a:extLst>
-          </p:cNvPr>
-          <p:cNvSpPr>
-            <a:spLocks noGrp="1"/>
-          </p:cNvSpPr>
-          <p:nvPr>
-            <p:ph type="title"/>
-          </p:nvPr>
-        </p:nvSpPr>
-        <p:spPr/>
-        <p:txBody>
-          <a:bodyPr/>
-          <a:lstStyle/>
-          <a:p>
-            <a:r>
-              <a:rPr lang="en-US" dirty="0"/>
-              <a:t>Strings</a:t>
-            </a:r>
-            <a:endParaRPr lang="en-BE" dirty="0"/>
-          </a:p>
-        </p:txBody>
-      </p:sp>
-      <p:sp>
-        <p:nvSpPr>
-          <p:cNvPr id="3" name="Content Placeholder 2">
-            <a:extLst>
-              <a:ext uri="{FF2B5EF4-FFF2-40B4-BE49-F238E27FC236}">
-                <a16:creationId xmlns:a16="http://schemas.microsoft.com/office/drawing/2014/main" id="{77C9CC8D-CD6B-4F74-8C2A-AC5ABCB3CCE2}"/>
-              </a:ext>
-            </a:extLst>
-          </p:cNvPr>
-          <p:cNvSpPr>
-            <a:spLocks noGrp="1"/>
-          </p:cNvSpPr>
-          <p:nvPr>
-            <p:ph idx="1"/>
-          </p:nvPr>
-        </p:nvSpPr>
-        <p:spPr/>
-        <p:txBody>
-          <a:bodyPr/>
-          <a:lstStyle/>
-          <a:p>
-            <a:r>
-              <a:rPr lang="en-US" dirty="0"/>
-              <a:t>Strings are different from integers and floats because they are </a:t>
-            </a:r>
-            <a:r>
-              <a:rPr lang="en-US" b="1" dirty="0"/>
-              <a:t>sequences </a:t>
-            </a:r>
-            <a:r>
-              <a:rPr lang="en-US" dirty="0"/>
-              <a:t>of characters</a:t>
-            </a:r>
-          </a:p>
-          <a:p>
-            <a:r>
-              <a:rPr lang="en-US" dirty="0"/>
-              <a:t>You can access individual characters using square brackets, remembering that Python starts counting </a:t>
-            </a:r>
-            <a:r>
-              <a:rPr lang="en-US" b="1" dirty="0"/>
-              <a:t>from 0!</a:t>
-            </a:r>
-            <a:endParaRPr lang="en-US" dirty="0"/>
-          </a:p>
-          <a:p>
-            <a:pPr marL="0" indent="0" algn="ctr">
-              <a:buNone/>
-            </a:pPr>
-            <a:r>
-              <a:rPr lang="en-US" dirty="0"/>
-              <a:t> </a:t>
-            </a:r>
-            <a:r>
-              <a:rPr lang="en-BE" dirty="0"/>
-              <a:t>"</a:t>
-            </a:r>
-            <a:r>
-              <a:rPr lang="en-US" dirty="0"/>
-              <a:t>hello</a:t>
-            </a:r>
-            <a:r>
-              <a:rPr lang="en-BE" dirty="0"/>
-              <a:t>“</a:t>
-            </a:r>
-            <a:r>
-              <a:rPr lang="en-US" dirty="0"/>
-              <a:t>[0] == </a:t>
-            </a:r>
-            <a:r>
-              <a:rPr lang="en-BE" dirty="0"/>
-              <a:t>"</a:t>
-            </a:r>
-            <a:r>
-              <a:rPr lang="en-US" dirty="0"/>
-              <a:t>h</a:t>
-            </a:r>
-            <a:r>
-              <a:rPr lang="en-BE" dirty="0"/>
-              <a:t>"</a:t>
-            </a:r>
-            <a:endParaRPr lang="en-US" dirty="0"/>
-          </a:p>
-          <a:p>
-            <a:r>
-              <a:rPr lang="en-US" dirty="0"/>
-              <a:t>You can use slices to select multiple characters. The right boundary is NOT included!</a:t>
-            </a:r>
-          </a:p>
-          <a:p>
-            <a:pPr marL="0" indent="0" algn="ctr">
-              <a:buNone/>
-            </a:pPr>
-            <a:r>
-              <a:rPr lang="en-BE" dirty="0"/>
-              <a:t>"</a:t>
-            </a:r>
-            <a:r>
-              <a:rPr lang="en-US" dirty="0"/>
-              <a:t>hello</a:t>
-            </a:r>
-            <a:r>
-              <a:rPr lang="en-BE" dirty="0"/>
-              <a:t>“</a:t>
-            </a:r>
-            <a:r>
-              <a:rPr lang="en-US" dirty="0"/>
-              <a:t>[1:4] == </a:t>
-            </a:r>
-            <a:r>
-              <a:rPr lang="en-BE" dirty="0"/>
-              <a:t>"</a:t>
-            </a:r>
-            <a:r>
-              <a:rPr lang="en-US" dirty="0"/>
-              <a:t>ell</a:t>
-            </a:r>
-            <a:r>
-              <a:rPr lang="en-BE" dirty="0"/>
-              <a:t>"</a:t>
-            </a:r>
-            <a:endParaRPr lang="en-US" dirty="0"/>
-          </a:p>
-          <a:p>
-            <a:r>
-              <a:rPr lang="en-US" dirty="0"/>
-              <a:t>Strings are </a:t>
-            </a:r>
-            <a:r>
-              <a:rPr lang="en-US" b="1" dirty="0"/>
-              <a:t>IMMUTABLE</a:t>
-            </a:r>
-          </a:p>
-        </p:txBody>
-      </p:sp>
-    </p:spTree>
-    <p:extLst>
-      <p:ext uri="{BB962C8B-B14F-4D97-AF65-F5344CB8AC3E}">
-        <p14:creationId xmlns:p14="http://schemas.microsoft.com/office/powerpoint/2010/main" val="1871610084"/>
       </p:ext>
     </p:extLst>
   </p:cSld>
@@ -11334,6 +11199,200 @@
           <p:cNvPr id="2" name="Title 1">
             <a:extLst>
               <a:ext uri="{FF2B5EF4-FFF2-40B4-BE49-F238E27FC236}">
+                <a16:creationId xmlns:a16="http://schemas.microsoft.com/office/drawing/2014/main" id="{C8C8D859-036E-2FBD-1F83-9D55BD4AD61D}"/>
+              </a:ext>
+            </a:extLst>
+          </p:cNvPr>
+          <p:cNvSpPr>
+            <a:spLocks noGrp="1"/>
+          </p:cNvSpPr>
+          <p:nvPr>
+            <p:ph type="title"/>
+          </p:nvPr>
+        </p:nvSpPr>
+        <p:spPr/>
+        <p:txBody>
+          <a:bodyPr/>
+          <a:lstStyle/>
+          <a:p>
+            <a:r>
+              <a:rPr lang="en-US" dirty="0"/>
+              <a:t>Strings</a:t>
+            </a:r>
+            <a:endParaRPr lang="en-BE" dirty="0"/>
+          </a:p>
+        </p:txBody>
+      </p:sp>
+      <p:sp>
+        <p:nvSpPr>
+          <p:cNvPr id="3" name="Content Placeholder 2">
+            <a:extLst>
+              <a:ext uri="{FF2B5EF4-FFF2-40B4-BE49-F238E27FC236}">
+                <a16:creationId xmlns:a16="http://schemas.microsoft.com/office/drawing/2014/main" id="{77C9CC8D-CD6B-4F74-8C2A-AC5ABCB3CCE2}"/>
+              </a:ext>
+            </a:extLst>
+          </p:cNvPr>
+          <p:cNvSpPr>
+            <a:spLocks noGrp="1"/>
+          </p:cNvSpPr>
+          <p:nvPr>
+            <p:ph idx="1"/>
+          </p:nvPr>
+        </p:nvSpPr>
+        <p:spPr/>
+        <p:txBody>
+          <a:bodyPr/>
+          <a:lstStyle/>
+          <a:p>
+            <a:r>
+              <a:rPr lang="en-US" dirty="0"/>
+              <a:t>Strings are different from integers and floats because they are </a:t>
+            </a:r>
+            <a:r>
+              <a:rPr lang="en-US" b="1" dirty="0"/>
+              <a:t>sequences </a:t>
+            </a:r>
+            <a:r>
+              <a:rPr lang="en-US" dirty="0"/>
+              <a:t>of characters</a:t>
+            </a:r>
+          </a:p>
+          <a:p>
+            <a:r>
+              <a:rPr lang="en-US" dirty="0"/>
+              <a:t>You can access individual characters using square brackets, remembering that Python starts counting </a:t>
+            </a:r>
+            <a:r>
+              <a:rPr lang="en-US" b="1" dirty="0"/>
+              <a:t>from 0!</a:t>
+            </a:r>
+            <a:endParaRPr lang="en-US" dirty="0"/>
+          </a:p>
+          <a:p>
+            <a:pPr marL="0" indent="0" algn="ctr">
+              <a:buNone/>
+            </a:pPr>
+            <a:r>
+              <a:rPr lang="en-US" dirty="0"/>
+              <a:t> </a:t>
+            </a:r>
+            <a:r>
+              <a:rPr lang="en-BE" dirty="0"/>
+              <a:t>"</a:t>
+            </a:r>
+            <a:r>
+              <a:rPr lang="en-US" dirty="0"/>
+              <a:t>hello</a:t>
+            </a:r>
+            <a:r>
+              <a:rPr lang="en-BE" dirty="0"/>
+              <a:t>“</a:t>
+            </a:r>
+            <a:r>
+              <a:rPr lang="en-US" dirty="0"/>
+              <a:t>[0] == </a:t>
+            </a:r>
+            <a:r>
+              <a:rPr lang="en-BE" dirty="0"/>
+              <a:t>"</a:t>
+            </a:r>
+            <a:r>
+              <a:rPr lang="en-US" dirty="0"/>
+              <a:t>h</a:t>
+            </a:r>
+            <a:r>
+              <a:rPr lang="en-BE" dirty="0"/>
+              <a:t>"</a:t>
+            </a:r>
+            <a:endParaRPr lang="en-US" dirty="0"/>
+          </a:p>
+          <a:p>
+            <a:r>
+              <a:rPr lang="en-US" dirty="0"/>
+              <a:t>You can use slices to select multiple characters. The right boundary is NOT included!</a:t>
+            </a:r>
+          </a:p>
+          <a:p>
+            <a:pPr marL="0" indent="0" algn="ctr">
+              <a:buNone/>
+            </a:pPr>
+            <a:r>
+              <a:rPr lang="en-BE" dirty="0"/>
+              <a:t>"</a:t>
+            </a:r>
+            <a:r>
+              <a:rPr lang="en-US" dirty="0"/>
+              <a:t>hello</a:t>
+            </a:r>
+            <a:r>
+              <a:rPr lang="en-BE" dirty="0"/>
+              <a:t>“</a:t>
+            </a:r>
+            <a:r>
+              <a:rPr lang="en-US" dirty="0"/>
+              <a:t>[1:4] == </a:t>
+            </a:r>
+            <a:r>
+              <a:rPr lang="en-BE" dirty="0"/>
+              <a:t>"</a:t>
+            </a:r>
+            <a:r>
+              <a:rPr lang="en-US" dirty="0"/>
+              <a:t>ell</a:t>
+            </a:r>
+            <a:r>
+              <a:rPr lang="en-BE" dirty="0"/>
+              <a:t>"</a:t>
+            </a:r>
+            <a:endParaRPr lang="en-US" dirty="0"/>
+          </a:p>
+          <a:p>
+            <a:r>
+              <a:rPr lang="en-US" dirty="0"/>
+              <a:t>Strings are </a:t>
+            </a:r>
+            <a:r>
+              <a:rPr lang="en-US" b="1" dirty="0"/>
+              <a:t>IMMUTABLE</a:t>
+            </a:r>
+          </a:p>
+        </p:txBody>
+      </p:sp>
+    </p:spTree>
+    <p:extLst>
+      <p:ext uri="{BB962C8B-B14F-4D97-AF65-F5344CB8AC3E}">
+        <p14:creationId xmlns:p14="http://schemas.microsoft.com/office/powerpoint/2010/main" val="1871610084"/>
+      </p:ext>
+    </p:extLst>
+  </p:cSld>
+  <p:clrMapOvr>
+    <a:masterClrMapping/>
+  </p:clrMapOvr>
+</p:sld>
+</file>
+
+<file path=ppt/slides/slide21.xml><?xml version="1.0" encoding="utf-8"?>
+<p:sld xmlns:a="http://schemas.openxmlformats.org/drawingml/2006/main" xmlns:r="http://schemas.openxmlformats.org/officeDocument/2006/relationships" xmlns:p="http://schemas.openxmlformats.org/presentationml/2006/main">
+  <p:cSld>
+    <p:spTree>
+      <p:nvGrpSpPr>
+        <p:cNvPr id="1" name=""/>
+        <p:cNvGrpSpPr/>
+        <p:nvPr/>
+      </p:nvGrpSpPr>
+      <p:grpSpPr>
+        <a:xfrm>
+          <a:off x="0" y="0"/>
+          <a:ext cx="0" cy="0"/>
+          <a:chOff x="0" y="0"/>
+          <a:chExt cx="0" cy="0"/>
+        </a:xfrm>
+      </p:grpSpPr>
+      <p:sp>
+        <p:nvSpPr>
+          <p:cNvPr id="2" name="Title 1">
+            <a:extLst>
+              <a:ext uri="{FF2B5EF4-FFF2-40B4-BE49-F238E27FC236}">
                 <a16:creationId xmlns:a16="http://schemas.microsoft.com/office/drawing/2014/main" id="{3884A60E-B9AB-C16C-8D65-3643EC9CD439}"/>
               </a:ext>
             </a:extLst>
@@ -11432,7 +11491,7 @@
 </p:sld>
 </file>
 
-<file path=ppt/slides/slide21.xml><?xml version="1.0" encoding="utf-8"?>
+<file path=ppt/slides/slide22.xml><?xml version="1.0" encoding="utf-8"?>
 <p:sld xmlns:a="http://schemas.openxmlformats.org/drawingml/2006/main" xmlns:r="http://schemas.openxmlformats.org/officeDocument/2006/relationships" xmlns:p="http://schemas.openxmlformats.org/presentationml/2006/main">
   <p:cSld>
     <p:spTree>
@@ -11627,7 +11686,7 @@
 </p:sld>
 </file>
 
-<file path=ppt/slides/slide22.xml><?xml version="1.0" encoding="utf-8"?>
+<file path=ppt/slides/slide23.xml><?xml version="1.0" encoding="utf-8"?>
 <p:sld xmlns:a="http://schemas.openxmlformats.org/drawingml/2006/main" xmlns:r="http://schemas.openxmlformats.org/officeDocument/2006/relationships" xmlns:p="http://schemas.openxmlformats.org/presentationml/2006/main">
   <p:cSld>
     <p:spTree>
@@ -11793,7 +11852,7 @@
 </p:sld>
 </file>
 
-<file path=ppt/slides/slide23.xml><?xml version="1.0" encoding="utf-8"?>
+<file path=ppt/slides/slide24.xml><?xml version="1.0" encoding="utf-8"?>
 <p:sld xmlns:a="http://schemas.openxmlformats.org/drawingml/2006/main" xmlns:r="http://schemas.openxmlformats.org/officeDocument/2006/relationships" xmlns:p="http://schemas.openxmlformats.org/presentationml/2006/main">
   <p:cSld>
     <p:spTree>
@@ -12039,7 +12098,7 @@
 </p:sld>
 </file>
 
-<file path=ppt/slides/slide24.xml><?xml version="1.0" encoding="utf-8"?>
+<file path=ppt/slides/slide25.xml><?xml version="1.0" encoding="utf-8"?>
 <p:sld xmlns:a="http://schemas.openxmlformats.org/drawingml/2006/main" xmlns:r="http://schemas.openxmlformats.org/officeDocument/2006/relationships" xmlns:p="http://schemas.openxmlformats.org/presentationml/2006/main">
   <p:cSld>
     <p:spTree>
@@ -12177,7 +12236,7 @@
 </p:sld>
 </file>
 
-<file path=ppt/slides/slide25.xml><?xml version="1.0" encoding="utf-8"?>
+<file path=ppt/slides/slide26.xml><?xml version="1.0" encoding="utf-8"?>
 <p:sld xmlns:a="http://schemas.openxmlformats.org/drawingml/2006/main" xmlns:r="http://schemas.openxmlformats.org/officeDocument/2006/relationships" xmlns:p="http://schemas.openxmlformats.org/presentationml/2006/main">
   <p:cSld>
     <p:spTree>
@@ -12456,7 +12515,7 @@
 </p:sld>
 </file>
 
-<file path=ppt/slides/slide26.xml><?xml version="1.0" encoding="utf-8"?>
+<file path=ppt/slides/slide27.xml><?xml version="1.0" encoding="utf-8"?>
 <p:sld xmlns:a="http://schemas.openxmlformats.org/drawingml/2006/main" xmlns:r="http://schemas.openxmlformats.org/officeDocument/2006/relationships" xmlns:p="http://schemas.openxmlformats.org/presentationml/2006/main">
   <p:cSld>
     <p:spTree>
@@ -12580,7 +12639,7 @@
 </p:sld>
 </file>
 
-<file path=ppt/slides/slide27.xml><?xml version="1.0" encoding="utf-8"?>
+<file path=ppt/slides/slide28.xml><?xml version="1.0" encoding="utf-8"?>
 <p:sld xmlns:a="http://schemas.openxmlformats.org/drawingml/2006/main" xmlns:r="http://schemas.openxmlformats.org/officeDocument/2006/relationships" xmlns:p="http://schemas.openxmlformats.org/presentationml/2006/main">
   <p:cSld>
     <p:spTree>
@@ -12755,7 +12814,7 @@
 </p:sld>
 </file>
 
-<file path=ppt/slides/slide28.xml><?xml version="1.0" encoding="utf-8"?>
+<file path=ppt/slides/slide29.xml><?xml version="1.0" encoding="utf-8"?>
 <p:sld xmlns:a="http://schemas.openxmlformats.org/drawingml/2006/main" xmlns:r="http://schemas.openxmlformats.org/officeDocument/2006/relationships" xmlns:p="http://schemas.openxmlformats.org/presentationml/2006/main">
   <p:cSld>
     <p:spTree>
@@ -12876,7 +12935,453 @@
 </p:sld>
 </file>
 
-<file path=ppt/slides/slide29.xml><?xml version="1.0" encoding="utf-8"?>
+<file path=ppt/slides/slide3.xml><?xml version="1.0" encoding="utf-8"?>
+<p:sld xmlns:a="http://schemas.openxmlformats.org/drawingml/2006/main" xmlns:r="http://schemas.openxmlformats.org/officeDocument/2006/relationships" xmlns:p="http://schemas.openxmlformats.org/presentationml/2006/main">
+  <p:cSld>
+    <p:bg>
+      <p:bgPr>
+        <a:solidFill>
+          <a:schemeClr val="bg1"/>
+        </a:solidFill>
+        <a:effectLst/>
+      </p:bgPr>
+    </p:bg>
+    <p:spTree>
+      <p:nvGrpSpPr>
+        <p:cNvPr id="1" name=""/>
+        <p:cNvGrpSpPr/>
+        <p:nvPr/>
+      </p:nvGrpSpPr>
+      <p:grpSpPr>
+        <a:xfrm>
+          <a:off x="0" y="0"/>
+          <a:ext cx="0" cy="0"/>
+          <a:chOff x="0" y="0"/>
+          <a:chExt cx="0" cy="0"/>
+        </a:xfrm>
+      </p:grpSpPr>
+      <p:sp useBgFill="1">
+        <p:nvSpPr>
+          <p:cNvPr id="1036" name="Rectangle 1035">
+            <a:extLst>
+              <a:ext uri="{FF2B5EF4-FFF2-40B4-BE49-F238E27FC236}">
+                <a16:creationId xmlns:a16="http://schemas.microsoft.com/office/drawing/2014/main" id="{CBB0869A-0BE5-B3E9-F73D-2F3691E4D932}"/>
+              </a:ext>
+              <a:ext uri="{C183D7F6-B498-43B3-948B-1728B52AA6E4}">
+                <adec:decorative xmlns:adec="http://schemas.microsoft.com/office/drawing/2017/decorative" val="1"/>
+              </a:ext>
+            </a:extLst>
+          </p:cNvPr>
+          <p:cNvSpPr>
+            <a:spLocks noGrp="1" noRot="1" noChangeAspect="1" noMove="1" noResize="1" noEditPoints="1" noAdjustHandles="1" noChangeArrowheads="1" noChangeShapeType="1" noTextEdit="1"/>
+          </p:cNvSpPr>
+          <p:nvPr>
+            <p:extLst>
+              <p:ext uri="{386F3935-93C4-4BCD-93E2-E3B085C9AB24}">
+                <p16:designElem xmlns:p16="http://schemas.microsoft.com/office/powerpoint/2015/main" val="1"/>
+              </p:ext>
+            </p:extLst>
+          </p:nvPr>
+        </p:nvSpPr>
+        <p:spPr>
+          <a:xfrm>
+            <a:off x="0" y="0"/>
+            <a:ext cx="12192000" cy="6858000"/>
+          </a:xfrm>
+          <a:prstGeom prst="rect">
+            <a:avLst/>
+          </a:prstGeom>
+          <a:ln w="12700" cap="flat" cmpd="sng" algn="ctr">
+            <a:noFill/>
+            <a:prstDash val="solid"/>
+            <a:miter lim="800000"/>
+          </a:ln>
+          <a:effectLst/>
+          <a:extLst>
+            <a:ext uri="{91240B29-F687-4F45-9708-019B960494DF}">
+              <a14:hiddenLine xmlns:a14="http://schemas.microsoft.com/office/drawing/2010/main" w="12700" cap="flat" cmpd="sng" algn="ctr">
+                <a:solidFill>
+                  <a:schemeClr val="accent1">
+                    <a:shade val="15000"/>
+                  </a:schemeClr>
+                </a:solidFill>
+                <a:prstDash val="solid"/>
+                <a:miter lim="800000"/>
+              </a14:hiddenLine>
+            </a:ext>
+          </a:extLst>
+        </p:spPr>
+        <p:style>
+          <a:lnRef idx="2">
+            <a:schemeClr val="accent1">
+              <a:shade val="15000"/>
+            </a:schemeClr>
+          </a:lnRef>
+          <a:fillRef idx="1">
+            <a:schemeClr val="accent1"/>
+          </a:fillRef>
+          <a:effectRef idx="0">
+            <a:schemeClr val="accent1"/>
+          </a:effectRef>
+          <a:fontRef idx="minor">
+            <a:schemeClr val="lt1"/>
+          </a:fontRef>
+        </p:style>
+        <p:txBody>
+          <a:bodyPr rtlCol="0" anchor="ctr"/>
+          <a:lstStyle/>
+          <a:p>
+            <a:pPr algn="ctr"/>
+            <a:endParaRPr lang="en-US"/>
+          </a:p>
+        </p:txBody>
+      </p:sp>
+      <p:sp>
+        <p:nvSpPr>
+          <p:cNvPr id="2" name="Titolo 1">
+            <a:extLst>
+              <a:ext uri="{FF2B5EF4-FFF2-40B4-BE49-F238E27FC236}">
+                <a16:creationId xmlns:a16="http://schemas.microsoft.com/office/drawing/2014/main" id="{494D33B3-0B15-8BEC-6A5C-059A0374852F}"/>
+              </a:ext>
+            </a:extLst>
+          </p:cNvPr>
+          <p:cNvSpPr>
+            <a:spLocks noGrp="1"/>
+          </p:cNvSpPr>
+          <p:nvPr>
+            <p:ph type="title"/>
+          </p:nvPr>
+        </p:nvSpPr>
+        <p:spPr>
+          <a:xfrm>
+            <a:off x="612648" y="1114923"/>
+            <a:ext cx="4621553" cy="1360728"/>
+          </a:xfrm>
+        </p:spPr>
+        <p:txBody>
+          <a:bodyPr anchor="b">
+            <a:normAutofit/>
+          </a:bodyPr>
+          <a:lstStyle/>
+          <a:p>
+            <a:r>
+              <a:rPr lang="it-IT" dirty="0"/>
+              <a:t>Python </a:t>
+            </a:r>
+            <a:r>
+              <a:rPr lang="it-IT" dirty="0" err="1"/>
+              <a:t>installation</a:t>
+            </a:r>
+            <a:endParaRPr lang="it-IT" dirty="0"/>
+          </a:p>
+        </p:txBody>
+      </p:sp>
+      <p:sp>
+        <p:nvSpPr>
+          <p:cNvPr id="3" name="Segnaposto contenuto 2">
+            <a:extLst>
+              <a:ext uri="{FF2B5EF4-FFF2-40B4-BE49-F238E27FC236}">
+                <a16:creationId xmlns:a16="http://schemas.microsoft.com/office/drawing/2014/main" id="{C73270CD-DEC2-7958-52DE-81F544B70367}"/>
+              </a:ext>
+            </a:extLst>
+          </p:cNvPr>
+          <p:cNvSpPr>
+            <a:spLocks noGrp="1"/>
+          </p:cNvSpPr>
+          <p:nvPr>
+            <p:ph idx="1"/>
+          </p:nvPr>
+        </p:nvSpPr>
+        <p:spPr>
+          <a:xfrm>
+            <a:off x="612648" y="2584058"/>
+            <a:ext cx="4621553" cy="3159018"/>
+          </a:xfrm>
+        </p:spPr>
+        <p:txBody>
+          <a:bodyPr>
+            <a:normAutofit/>
+          </a:bodyPr>
+          <a:lstStyle/>
+          <a:p>
+            <a:pPr>
+              <a:lnSpc>
+                <a:spcPct val="110000"/>
+              </a:lnSpc>
+            </a:pPr>
+            <a:r>
+              <a:rPr lang="it-IT" sz="1500" dirty="0"/>
+              <a:t>Anaconda </a:t>
+            </a:r>
+            <a:r>
+              <a:rPr lang="it-IT" sz="1500" dirty="0" err="1"/>
+              <a:t>is</a:t>
+            </a:r>
+            <a:r>
+              <a:rPr lang="it-IT" sz="1500" dirty="0"/>
+              <a:t> a Python </a:t>
+            </a:r>
+            <a:r>
+              <a:rPr lang="it-IT" sz="1500" dirty="0" err="1"/>
+              <a:t>distribution</a:t>
+            </a:r>
+            <a:r>
+              <a:rPr lang="it-IT" sz="1500" dirty="0"/>
+              <a:t> </a:t>
+            </a:r>
+            <a:r>
+              <a:rPr lang="it-IT" sz="1500" dirty="0" err="1"/>
+              <a:t>that</a:t>
+            </a:r>
+            <a:r>
+              <a:rPr lang="it-IT" sz="1500" dirty="0"/>
+              <a:t> </a:t>
+            </a:r>
+            <a:r>
+              <a:rPr lang="it-IT" sz="1500" dirty="0" err="1"/>
+              <a:t>includes</a:t>
+            </a:r>
+            <a:r>
+              <a:rPr lang="it-IT" sz="1500" dirty="0"/>
+              <a:t> a GUI, </a:t>
+            </a:r>
+            <a:r>
+              <a:rPr lang="it-IT" sz="1500" dirty="0" err="1"/>
+              <a:t>several</a:t>
+            </a:r>
+            <a:r>
+              <a:rPr lang="it-IT" sz="1500" dirty="0"/>
+              <a:t> </a:t>
+            </a:r>
+            <a:r>
+              <a:rPr lang="it-IT" sz="1500" dirty="0" err="1"/>
+              <a:t>IDEs</a:t>
+            </a:r>
+            <a:r>
+              <a:rPr lang="it-IT" sz="1500" dirty="0"/>
+              <a:t> to </a:t>
+            </a:r>
+            <a:r>
+              <a:rPr lang="it-IT" sz="1500" dirty="0" err="1"/>
+              <a:t>choose</a:t>
+            </a:r>
+            <a:r>
+              <a:rPr lang="it-IT" sz="1500" dirty="0"/>
+              <a:t> from and a </a:t>
+            </a:r>
+            <a:r>
+              <a:rPr lang="it-IT" sz="1500" dirty="0" err="1"/>
+              <a:t>collection</a:t>
+            </a:r>
+            <a:r>
+              <a:rPr lang="it-IT" sz="1500" dirty="0"/>
+              <a:t> of </a:t>
+            </a:r>
+            <a:r>
+              <a:rPr lang="it-IT" sz="1500" dirty="0" err="1"/>
+              <a:t>commonly</a:t>
+            </a:r>
+            <a:r>
+              <a:rPr lang="it-IT" sz="1500" dirty="0"/>
+              <a:t> </a:t>
+            </a:r>
+            <a:r>
+              <a:rPr lang="it-IT" sz="1500" dirty="0" err="1"/>
+              <a:t>used</a:t>
+            </a:r>
+            <a:r>
+              <a:rPr lang="it-IT" sz="1500" dirty="0"/>
+              <a:t> packages.</a:t>
+            </a:r>
+          </a:p>
+          <a:p>
+            <a:pPr>
+              <a:lnSpc>
+                <a:spcPct val="110000"/>
+              </a:lnSpc>
+            </a:pPr>
+            <a:endParaRPr lang="it-IT" sz="1500" dirty="0"/>
+          </a:p>
+          <a:p>
+            <a:pPr>
+              <a:lnSpc>
+                <a:spcPct val="110000"/>
+              </a:lnSpc>
+            </a:pPr>
+            <a:r>
+              <a:rPr lang="it-IT" sz="1500" dirty="0" err="1"/>
+              <a:t>Available</a:t>
+            </a:r>
+            <a:r>
+              <a:rPr lang="it-IT" sz="1500" dirty="0"/>
+              <a:t> for Windows, </a:t>
+            </a:r>
+            <a:r>
+              <a:rPr lang="it-IT" sz="1500" dirty="0" err="1"/>
+              <a:t>macOS</a:t>
+            </a:r>
+            <a:r>
+              <a:rPr lang="it-IT" sz="1500" dirty="0"/>
+              <a:t> and Linux</a:t>
+            </a:r>
+          </a:p>
+          <a:p>
+            <a:pPr>
+              <a:lnSpc>
+                <a:spcPct val="110000"/>
+              </a:lnSpc>
+            </a:pPr>
+            <a:endParaRPr lang="it-IT" sz="1500" dirty="0"/>
+          </a:p>
+          <a:p>
+            <a:pPr>
+              <a:lnSpc>
+                <a:spcPct val="110000"/>
+              </a:lnSpc>
+            </a:pPr>
+            <a:r>
+              <a:rPr lang="it-IT" sz="1500" dirty="0" err="1"/>
+              <a:t>Beware</a:t>
+            </a:r>
+            <a:r>
+              <a:rPr lang="it-IT" sz="1500" dirty="0"/>
+              <a:t> of PATH </a:t>
+            </a:r>
+            <a:r>
+              <a:rPr lang="it-IT" sz="1500" dirty="0" err="1"/>
+              <a:t>issues</a:t>
+            </a:r>
+            <a:r>
+              <a:rPr lang="it-IT" sz="1500" dirty="0"/>
+              <a:t> on Windows. The </a:t>
+            </a:r>
+            <a:r>
+              <a:rPr lang="it-IT" sz="1500" dirty="0" err="1"/>
+              <a:t>advice</a:t>
+            </a:r>
+            <a:r>
+              <a:rPr lang="it-IT" sz="1500" dirty="0"/>
+              <a:t> </a:t>
+            </a:r>
+            <a:r>
+              <a:rPr lang="it-IT" sz="1500" dirty="0" err="1"/>
+              <a:t>is</a:t>
+            </a:r>
+            <a:r>
+              <a:rPr lang="it-IT" sz="1500" dirty="0"/>
+              <a:t> to </a:t>
+            </a:r>
+            <a:r>
+              <a:rPr lang="it-IT" sz="1500" dirty="0" err="1"/>
+              <a:t>not</a:t>
+            </a:r>
+            <a:r>
+              <a:rPr lang="it-IT" sz="1500" dirty="0"/>
+              <a:t> </a:t>
+            </a:r>
+            <a:r>
+              <a:rPr lang="it-IT" sz="1500" dirty="0" err="1"/>
+              <a:t>add</a:t>
+            </a:r>
+            <a:r>
+              <a:rPr lang="it-IT" sz="1500" dirty="0"/>
+              <a:t> </a:t>
+            </a:r>
+            <a:r>
+              <a:rPr lang="it-IT" sz="1500" dirty="0" err="1"/>
+              <a:t>conda</a:t>
+            </a:r>
+            <a:r>
+              <a:rPr lang="it-IT" sz="1500" dirty="0"/>
+              <a:t> to the </a:t>
+            </a:r>
+            <a:r>
+              <a:rPr lang="it-IT" sz="1500" dirty="0" err="1"/>
+              <a:t>Path</a:t>
+            </a:r>
+            <a:r>
+              <a:rPr lang="it-IT" sz="1500" dirty="0"/>
+              <a:t> and use Anaconda </a:t>
+            </a:r>
+            <a:r>
+              <a:rPr lang="it-IT" sz="1500" dirty="0" err="1"/>
+              <a:t>Command</a:t>
+            </a:r>
+            <a:r>
+              <a:rPr lang="it-IT" sz="1500" dirty="0"/>
+              <a:t> Prompt</a:t>
+            </a:r>
+          </a:p>
+          <a:p>
+            <a:pPr>
+              <a:lnSpc>
+                <a:spcPct val="110000"/>
+              </a:lnSpc>
+            </a:pPr>
+            <a:endParaRPr lang="it-IT" sz="1500" dirty="0"/>
+          </a:p>
+        </p:txBody>
+      </p:sp>
+      <p:pic>
+        <p:nvPicPr>
+          <p:cNvPr id="1026" name="Picture 2" descr="Install Anaconda for Machine Learning and Data Science in Python">
+            <a:extLst>
+              <a:ext uri="{FF2B5EF4-FFF2-40B4-BE49-F238E27FC236}">
+                <a16:creationId xmlns:a16="http://schemas.microsoft.com/office/drawing/2014/main" id="{2670CDB7-9E6C-3EC8-9AF5-6EF7C24252F5}"/>
+              </a:ext>
+            </a:extLst>
+          </p:cNvPr>
+          <p:cNvPicPr>
+            <a:picLocks noChangeAspect="1" noChangeArrowheads="1"/>
+          </p:cNvPicPr>
+          <p:nvPr/>
+        </p:nvPicPr>
+        <p:blipFill>
+          <a:blip r:embed="rId2">
+            <a:extLst>
+              <a:ext uri="{28A0092B-C50C-407E-A947-70E740481C1C}">
+                <a14:useLocalDpi xmlns:a14="http://schemas.microsoft.com/office/drawing/2010/main" val="0"/>
+              </a:ext>
+            </a:extLst>
+          </a:blip>
+          <a:stretch>
+            <a:fillRect/>
+          </a:stretch>
+        </p:blipFill>
+        <p:spPr bwMode="auto">
+          <a:xfrm>
+            <a:off x="5691261" y="1969554"/>
+            <a:ext cx="5837780" cy="2918890"/>
+          </a:xfrm>
+          <a:prstGeom prst="rect">
+            <a:avLst/>
+          </a:prstGeom>
+          <a:noFill/>
+          <a:extLst>
+            <a:ext uri="{909E8E84-426E-40DD-AFC4-6F175D3DCCD1}">
+              <a14:hiddenFill xmlns:a14="http://schemas.microsoft.com/office/drawing/2010/main">
+                <a:solidFill>
+                  <a:srgbClr val="FFFFFF"/>
+                </a:solidFill>
+              </a14:hiddenFill>
+            </a:ext>
+          </a:extLst>
+        </p:spPr>
+      </p:pic>
+    </p:spTree>
+    <p:extLst>
+      <p:ext uri="{BB962C8B-B14F-4D97-AF65-F5344CB8AC3E}">
+        <p14:creationId xmlns:p14="http://schemas.microsoft.com/office/powerpoint/2010/main" val="3164938394"/>
+      </p:ext>
+    </p:extLst>
+  </p:cSld>
+  <p:clrMapOvr>
+    <a:masterClrMapping/>
+  </p:clrMapOvr>
+</p:sld>
+</file>
+
+<file path=ppt/slides/slide30.xml><?xml version="1.0" encoding="utf-8"?>
 <p:sld xmlns:a="http://schemas.openxmlformats.org/drawingml/2006/main" xmlns:r="http://schemas.openxmlformats.org/officeDocument/2006/relationships" xmlns:p="http://schemas.openxmlformats.org/presentationml/2006/main">
   <p:cSld>
     <p:spTree>
@@ -12975,11 +13480,7 @@
           <a:p>
             <a:r>
               <a:rPr lang="en-US" dirty="0"/>
-              <a:t>Tuple packing is used to have functions return </a:t>
-            </a:r>
-            <a:r>
-              <a:rPr lang="en-US"/>
-              <a:t>multiple values</a:t>
+              <a:t>Tuple packing is used to have functions return multiple values</a:t>
             </a:r>
           </a:p>
         </p:txBody>
@@ -12997,7 +13498,7 @@
 </p:sld>
 </file>
 
-<file path=ppt/slides/slide3.xml><?xml version="1.0" encoding="utf-8"?>
+<file path=ppt/slides/slide4.xml><?xml version="1.0" encoding="utf-8"?>
 <p:sld xmlns:a="http://schemas.openxmlformats.org/drawingml/2006/main" xmlns:r="http://schemas.openxmlformats.org/officeDocument/2006/relationships" xmlns:p="http://schemas.openxmlformats.org/presentationml/2006/main">
   <p:cSld>
     <p:bg>
@@ -13192,7 +13693,7 @@
 </p:sld>
 </file>
 
-<file path=ppt/slides/slide4.xml><?xml version="1.0" encoding="utf-8"?>
+<file path=ppt/slides/slide5.xml><?xml version="1.0" encoding="utf-8"?>
 <p:sld xmlns:a="http://schemas.openxmlformats.org/drawingml/2006/main" xmlns:r="http://schemas.openxmlformats.org/officeDocument/2006/relationships" xmlns:p="http://schemas.openxmlformats.org/presentationml/2006/main">
   <p:cSld>
     <p:spTree>
@@ -13338,7 +13839,7 @@
 </p:sld>
 </file>
 
-<file path=ppt/slides/slide5.xml><?xml version="1.0" encoding="utf-8"?>
+<file path=ppt/slides/slide6.xml><?xml version="1.0" encoding="utf-8"?>
 <p:sld xmlns:a="http://schemas.openxmlformats.org/drawingml/2006/main" xmlns:r="http://schemas.openxmlformats.org/officeDocument/2006/relationships" xmlns:p="http://schemas.openxmlformats.org/presentationml/2006/main">
   <p:cSld>
     <p:bg>
@@ -13527,7 +14028,7 @@
 </p:sld>
 </file>
 
-<file path=ppt/slides/slide6.xml><?xml version="1.0" encoding="utf-8"?>
+<file path=ppt/slides/slide7.xml><?xml version="1.0" encoding="utf-8"?>
 <p:sld xmlns:a="http://schemas.openxmlformats.org/drawingml/2006/main" xmlns:r="http://schemas.openxmlformats.org/officeDocument/2006/relationships" xmlns:p="http://schemas.openxmlformats.org/presentationml/2006/main">
   <p:cSld>
     <p:spTree>
@@ -13609,7 +14110,7 @@
 </p:sld>
 </file>
 
-<file path=ppt/slides/slide7.xml><?xml version="1.0" encoding="utf-8"?>
+<file path=ppt/slides/slide8.xml><?xml version="1.0" encoding="utf-8"?>
 <p:sld xmlns:a="http://schemas.openxmlformats.org/drawingml/2006/main" xmlns:r="http://schemas.openxmlformats.org/officeDocument/2006/relationships" xmlns:p="http://schemas.openxmlformats.org/presentationml/2006/main">
   <p:cSld>
     <p:spTree>
@@ -13731,7 +14232,7 @@
 </p:sld>
 </file>
 
-<file path=ppt/slides/slide8.xml><?xml version="1.0" encoding="utf-8"?>
+<file path=ppt/slides/slide9.xml><?xml version="1.0" encoding="utf-8"?>
 <p:sld xmlns:a="http://schemas.openxmlformats.org/drawingml/2006/main" xmlns:r="http://schemas.openxmlformats.org/officeDocument/2006/relationships" xmlns:p="http://schemas.openxmlformats.org/presentationml/2006/main">
   <p:cSld>
     <p:spTree>
@@ -13872,155 +14373,6 @@
     <p:extLst>
       <p:ext uri="{BB962C8B-B14F-4D97-AF65-F5344CB8AC3E}">
         <p14:creationId xmlns:p14="http://schemas.microsoft.com/office/powerpoint/2010/main" val="3708691995"/>
-      </p:ext>
-    </p:extLst>
-  </p:cSld>
-  <p:clrMapOvr>
-    <a:masterClrMapping/>
-  </p:clrMapOvr>
-</p:sld>
-</file>
-
-<file path=ppt/slides/slide9.xml><?xml version="1.0" encoding="utf-8"?>
-<p:sld xmlns:a="http://schemas.openxmlformats.org/drawingml/2006/main" xmlns:r="http://schemas.openxmlformats.org/officeDocument/2006/relationships" xmlns:p="http://schemas.openxmlformats.org/presentationml/2006/main">
-  <p:cSld>
-    <p:spTree>
-      <p:nvGrpSpPr>
-        <p:cNvPr id="1" name=""/>
-        <p:cNvGrpSpPr/>
-        <p:nvPr/>
-      </p:nvGrpSpPr>
-      <p:grpSpPr>
-        <a:xfrm>
-          <a:off x="0" y="0"/>
-          <a:ext cx="0" cy="0"/>
-          <a:chOff x="0" y="0"/>
-          <a:chExt cx="0" cy="0"/>
-        </a:xfrm>
-      </p:grpSpPr>
-      <p:sp>
-        <p:nvSpPr>
-          <p:cNvPr id="2" name="Title 1">
-            <a:extLst>
-              <a:ext uri="{FF2B5EF4-FFF2-40B4-BE49-F238E27FC236}">
-                <a16:creationId xmlns:a16="http://schemas.microsoft.com/office/drawing/2014/main" id="{6DFACE75-B5B1-A22A-A7D1-B9F6CCFF82DC}"/>
-              </a:ext>
-            </a:extLst>
-          </p:cNvPr>
-          <p:cNvSpPr>
-            <a:spLocks noGrp="1"/>
-          </p:cNvSpPr>
-          <p:nvPr>
-            <p:ph type="title"/>
-          </p:nvPr>
-        </p:nvSpPr>
-        <p:spPr/>
-        <p:txBody>
-          <a:bodyPr/>
-          <a:lstStyle/>
-          <a:p>
-            <a:r>
-              <a:rPr lang="en-US" dirty="0"/>
-              <a:t>Values and types recap</a:t>
-            </a:r>
-            <a:endParaRPr lang="en-BE" dirty="0"/>
-          </a:p>
-        </p:txBody>
-      </p:sp>
-      <p:sp>
-        <p:nvSpPr>
-          <p:cNvPr id="3" name="Content Placeholder 2">
-            <a:extLst>
-              <a:ext uri="{FF2B5EF4-FFF2-40B4-BE49-F238E27FC236}">
-                <a16:creationId xmlns:a16="http://schemas.microsoft.com/office/drawing/2014/main" id="{E341C943-4128-57D6-3A17-5410C64AC24E}"/>
-              </a:ext>
-            </a:extLst>
-          </p:cNvPr>
-          <p:cNvSpPr>
-            <a:spLocks noGrp="1"/>
-          </p:cNvSpPr>
-          <p:nvPr>
-            <p:ph idx="1"/>
-          </p:nvPr>
-        </p:nvSpPr>
-        <p:spPr/>
-        <p:txBody>
-          <a:bodyPr/>
-          <a:lstStyle/>
-          <a:p>
-            <a:r>
-              <a:rPr lang="en-US" b="1" dirty="0"/>
-              <a:t>Integer </a:t>
-            </a:r>
-            <a:r>
-              <a:rPr lang="en-US" dirty="0"/>
-              <a:t>(2)</a:t>
-            </a:r>
-          </a:p>
-          <a:p>
-            <a:endParaRPr lang="en-US" dirty="0"/>
-          </a:p>
-          <a:p>
-            <a:r>
-              <a:rPr lang="en-US" b="1" dirty="0"/>
-              <a:t>Float</a:t>
-            </a:r>
-            <a:r>
-              <a:rPr lang="en-US" dirty="0"/>
-              <a:t> (42.3)</a:t>
-            </a:r>
-          </a:p>
-          <a:p>
-            <a:endParaRPr lang="en-US" b="1" dirty="0"/>
-          </a:p>
-          <a:p>
-            <a:r>
-              <a:rPr lang="en-US" b="1" dirty="0"/>
-              <a:t>String</a:t>
-            </a:r>
-            <a:r>
-              <a:rPr lang="en-US" dirty="0"/>
-              <a:t> (</a:t>
-            </a:r>
-            <a:r>
-              <a:rPr lang="en-BE" dirty="0"/>
-              <a:t>"</a:t>
-            </a:r>
-            <a:r>
-              <a:rPr lang="en-US" dirty="0"/>
-              <a:t>hello</a:t>
-            </a:r>
-            <a:r>
-              <a:rPr lang="en-BE" dirty="0"/>
-              <a:t>"</a:t>
-            </a:r>
-            <a:r>
-              <a:rPr lang="en-US" dirty="0"/>
-              <a:t>)</a:t>
-            </a:r>
-          </a:p>
-          <a:p>
-            <a:endParaRPr lang="en-US" dirty="0"/>
-          </a:p>
-          <a:p>
-            <a:r>
-              <a:rPr lang="en-US" dirty="0"/>
-              <a:t>The type() function tells you what type a value is</a:t>
-            </a:r>
-          </a:p>
-          <a:p>
-            <a:r>
-              <a:rPr lang="en-US" dirty="0"/>
-              <a:t>Int(), float() and str() are functions that convert their argument to the specified type (if possible)</a:t>
-            </a:r>
-            <a:endParaRPr lang="en-BE" dirty="0"/>
-          </a:p>
-        </p:txBody>
-      </p:sp>
-    </p:spTree>
-    <p:extLst>
-      <p:ext uri="{BB962C8B-B14F-4D97-AF65-F5344CB8AC3E}">
-        <p14:creationId xmlns:p14="http://schemas.microsoft.com/office/powerpoint/2010/main" val="2067501582"/>
       </p:ext>
     </p:extLst>
   </p:cSld>
@@ -14238,6 +14590,15 @@
 </file>
 
 <file path=customXml/item2.xml><?xml version="1.0" encoding="utf-8"?>
+<?mso-contentType ?>
+<FormTemplates xmlns="http://schemas.microsoft.com/sharepoint/v3/contenttype/forms">
+  <Display>DocumentLibraryForm</Display>
+  <Edit>DocumentLibraryForm</Edit>
+  <New>DocumentLibraryForm</New>
+</FormTemplates>
+</file>
+
+<file path=customXml/item3.xml><?xml version="1.0" encoding="utf-8"?>
 <ct:contentTypeSchema xmlns:ct="http://schemas.microsoft.com/office/2006/metadata/contentType" xmlns:ma="http://schemas.microsoft.com/office/2006/metadata/properties/metaAttributes" ct:_="" ma:_="" ma:contentTypeName="Document" ma:contentTypeID="0x010100F50237F90CC9F849A301EC8DD892D112" ma:contentTypeVersion="4" ma:contentTypeDescription="Een nieuw document maken." ma:contentTypeScope="" ma:versionID="afe2fa194fee0eaf1453672f13a23597">
   <xsd:schema xmlns:xsd="http://www.w3.org/2001/XMLSchema" xmlns:xs="http://www.w3.org/2001/XMLSchema" xmlns:p="http://schemas.microsoft.com/office/2006/metadata/properties" xmlns:ns3="9b686549-2dc3-4bd0-b152-734f9779ea1f" targetNamespace="http://schemas.microsoft.com/office/2006/metadata/properties" ma:root="true" ma:fieldsID="c3a672704b3ed74c94cd6d0e7f1e6c63" ns3:_="">
     <xsd:import namespace="9b686549-2dc3-4bd0-b152-734f9779ea1f"/>
@@ -14381,15 +14742,6 @@
 </ct:contentTypeSchema>
 </file>
 
-<file path=customXml/item3.xml><?xml version="1.0" encoding="utf-8"?>
-<?mso-contentType ?>
-<FormTemplates xmlns="http://schemas.microsoft.com/sharepoint/v3/contenttype/forms">
-  <Display>DocumentLibraryForm</Display>
-  <Edit>DocumentLibraryForm</Edit>
-  <New>DocumentLibraryForm</New>
-</FormTemplates>
-</file>
-
 <file path=customXml/itemProps1.xml><?xml version="1.0" encoding="utf-8"?>
 <ds:datastoreItem xmlns:ds="http://schemas.openxmlformats.org/officeDocument/2006/customXml" ds:itemID="{BCCD18BD-1104-41D7-BAB2-73D9416C5A8D}">
   <ds:schemaRefs>
@@ -14407,6 +14759,14 @@
 </file>
 
 <file path=customXml/itemProps2.xml><?xml version="1.0" encoding="utf-8"?>
+<ds:datastoreItem xmlns:ds="http://schemas.openxmlformats.org/officeDocument/2006/customXml" ds:itemID="{1A154E21-7F55-4002-81DC-AA9AB0955A50}">
+  <ds:schemaRefs>
+    <ds:schemaRef ds:uri="http://schemas.microsoft.com/sharepoint/v3/contenttype/forms"/>
+  </ds:schemaRefs>
+</ds:datastoreItem>
+</file>
+
+<file path=customXml/itemProps3.xml><?xml version="1.0" encoding="utf-8"?>
 <ds:datastoreItem xmlns:ds="http://schemas.openxmlformats.org/officeDocument/2006/customXml" ds:itemID="{0F758E7D-8261-4C04-82F6-42601BDC8C37}">
   <ds:schemaRefs>
     <ds:schemaRef ds:uri="http://schemas.microsoft.com/office/2006/metadata/contentType"/>
@@ -14422,12 +14782,4 @@
     <ds:schemaRef ds:uri="http://schemas.microsoft.com/internal/obd"/>
   </ds:schemaRefs>
 </ds:datastoreItem>
-</file>
-
-<file path=customXml/itemProps3.xml><?xml version="1.0" encoding="utf-8"?>
-<ds:datastoreItem xmlns:ds="http://schemas.openxmlformats.org/officeDocument/2006/customXml" ds:itemID="{1A154E21-7F55-4002-81DC-AA9AB0955A50}">
-  <ds:schemaRefs>
-    <ds:schemaRef ds:uri="http://schemas.microsoft.com/sharepoint/v3/contenttype/forms"/>
-  </ds:schemaRefs>
-</ds:datastoreItem>
 </file>
</xml_diff>